<commit_message>
Make every published number match the live system
The deployed landing page still hardcoded 23 standards / 115 chunks
from an old build while the index actually holds 28 / 122, and the
site had claims (hallucination-free, 95% verified, dead deck URL)
that the jury flagged as unsupported. Landing page now reads counts
from GET /api/stats (single source of truth), the RAG engine gets
eval-driven fixes (relevance floor, diversify, abstention on
off-topic queries), auth gains JWT+bcrypt, and an eval harness
records the measured numbers (97.8% citation verification, 100%
off-topic refusal) used across docs and the deck.

🤖 Generated with Codebuff
Co-Authored-By: Codebuff <noreply@codebuff.com>
</commit_message>
<xml_diff>
--- a/ManakMitra_SIH2026_v5.pptx
+++ b/ManakMitra_SIH2026_v5.pptx
@@ -6452,7 +6452,7 @@
                   <a:srgbClr val="333333"/>
                 </a:solidFill>
               </a:rPr>
-              <a:t> - ONNX + FAISS, hallucination-free, cited responses</a:t>
+              <a:t> - ONNX + FAISS, citation-verified, source-grounded responses</a:t>
             </a:r>
           </a:p>
           <a:p>
@@ -7331,7 +7331,7 @@
                   <a:srgbClr val="2196F3"/>
                 </a:solidFill>
               </a:rPr>
-              <a:t>manakmitra-frontend.vercel.app</a:t>
+              <a:t>sih2026-bis-assistant-ebon.vercel.app</a:t>
             </a:r>
           </a:p>
         </p:txBody>
@@ -9510,7 +9510,7 @@
                   <a:srgbClr val="1A3A6E"/>
                 </a:solidFill>
               </a:rPr>
-              <a:t>Hallucination-Free RAG</a:t>
+              <a:t>Citation-Verified RAG</a:t>
             </a:r>
           </a:p>
           <a:p>
@@ -10882,7 +10882,7 @@
                   <a:srgbClr val="333333"/>
                 </a:solidFill>
               </a:rPr>
-              <a:t>1. IS Standards: IS 269, IS 455, IS 8112</a:t>
+              <a:t>1. IS Standards: IS 269, IS 455, IS 1489</a:t>
             </a:r>
           </a:p>
         </p:txBody>
@@ -12326,7 +12326,7 @@
                   <a:srgbClr val="333333"/>
                 </a:solidFill>
               </a:rPr>
-              <a:t> 63M+ MSMEs in India struggle with BIS compliance. No free AI tool exists for this.</a:t>
+              <a:t> 63M+ MSMEs in India struggle with BIS compliance. Free AI tools answer generically - none indexes official IS text with citations.</a:t>
             </a:r>
           </a:p>
           <a:p>
@@ -12419,7 +12419,7 @@
                   <a:srgbClr val="333333"/>
                 </a:solidFill>
               </a:rPr>
-              <a:t> Source-grounded RAG ensures responses cite official BIS documents. No hallucinations.</a:t>
+              <a:t> Cited sources on every answer; 97.8% of IS references verified against retrieved text (28-question eval harness in repo).</a:t>
             </a:r>
           </a:p>
           <a:p>
@@ -12481,7 +12481,7 @@
                   <a:srgbClr val="333333"/>
                 </a:solidFill>
               </a:rPr>
-              <a:t> Potential BIS official data provider status. Revenue share on certified leads.</a:t>
+              <a:t> No committed partners yet - outreach planned to BIS-recognized labs and MSME bodies; freemium subscriptions as the revenue model.</a:t>
             </a:r>
           </a:p>
         </p:txBody>
@@ -15809,7 +15809,7 @@
                   <a:srgbClr val="333333"/>
                 </a:solidFill>
               </a:rPr>
-              <a:t> All responses cite official BIS documents. Zero hallucinations.</a:t>
+              <a:t> All responses cite official BIS documents; 97.8% of references verified in a 28-question eval.</a:t>
             </a:r>
           </a:p>
           <a:p>
@@ -16267,7 +16267,7 @@
                   <a:srgbClr val="333333"/>
                 </a:solidFill>
               </a:rPr>
-              <a:t>BIS Data Licensing    Rs. 60,000      15.58%        </a:t>
+              <a:t>Data Engineering    Rs. 60,000      15.58%        </a:t>
             </a:r>
             <a:r>
               <a:rPr sz="800" b="1">
@@ -16924,7 +16924,7 @@
                   <a:srgbClr val="FF6B35"/>
                 </a:solidFill>
               </a:rPr>
-              <a:t>manakmitra-frontend.vercel.app</a:t>
+              <a:t>sih2026-bis-assistant-ebon.vercel.app</a:t>
             </a:r>
           </a:p>
         </p:txBody>

</xml_diff>